<commit_message>
Add PoC page and PDF, final deck v2, team name, IoT wording, wiring MOSFET note
Co-Authored-By: Claude Opus 5.5 <noreply@anthropic.com>
</commit_message>
<xml_diff>
--- a/docs/e-nose-pitch-deck-v2.pptx
+++ b/docs/e-nose-pitch-deck-v2.pptx
@@ -517,7 +517,7 @@
           <a:lstStyle/>
           <a:p>
             <a:r>
-              <a:t>สวัสดีครับ วันนี้เสนอ "เครื่องดมทุเรียน" เครื่องตรวจความสุกและการเสียของทุเรียนจากกลิ่น ด้วยเซนเซอร์แก๊สหลายตัวบน ESP32 มีสองรุ่นคือ DS-300 เครื่องคัดแบบพกพาสำหรับล้ง และ E-100 เครื่องตั้งโต๊ะสำหรับร้านพรีเมียม ทั้งสองรุ่นเป็นแนวคิด ยังไม่ได้สร้างจริง และเรายังไม่มีผลทดลองจากเครื่องของเราเอง</a:t>
+              <a:t>สวัสดีครับ วันนี้เสนอ "เครื่องดมทุเรียนอัจฉริยะ" เครื่องตรวจความสุกและการเสียของทุเรียนจากกลิ่น ด้วยเซนเซอร์แก๊สหลายตัวบน ESP32 มีสองรุ่นคือ DS-300 เครื่องคัดแบบพกพาสำหรับล้ง และ E-100 เครื่องตั้งโต๊ะสำหรับร้านพรีเมียม ทั้งสองรุ่นเป็นแนวคิด ยังไม่ได้สร้างจริง และเรายังไม่มีผลทดลองจากเครื่องของเราเอง</a:t>
             </a:r>
           </a:p>
         </p:txBody>
@@ -937,7 +937,7 @@
           <a:lstStyle/>
           <a:p>
             <a:r>
-              <a:t>ทีมมี 3 คน สาย IoT จาก All for One University ในโครงการ Internet of Thailand ผู้นำเสนอคือ ณัฐพฤทธ์ เอกประเสริฐ เราขอคำชี้แนะจากกรรมการสามข้อ หนึ่ง ควรเริ่มทดสอบ DS-300 ที่ล้ง หรือ E-100 ที่ร้านก่อน สอง ควรลงทุนเซนเซอร์ระดับ B ตั้งแต่ต้น หรือพิสูจน์ด้วยชุด A ก่อน สาม มีล้งหรือหน่วยงานไหนที่ควรติดต่อเพื่อเก็บข้อมูลจริง</a:t>
+              <a:t>ทีม พี่จร้าาา สาย IoT &amp; Innovation ในงาน IoTE KMITL 2026 Showcase ผู้นำเสนอคือ ณัฐพฤทธ์ เอกประเสริฐ เราขอคำชี้แนะจากกรรมการสามข้อ หนึ่ง ควรเริ่มทดสอบ DS-300 ที่ล้ง หรือ E-100 ที่ร้านก่อน สอง ควรลงทุนเซนเซอร์ระดับ B ตั้งแต่ต้น หรือพิสูจน์ด้วยชุด A ก่อน สาม มีล้งหรือหน่วยงานไหนที่ควรติดต่อเพื่อเก็บข้อมูลจริง</a:t>
             </a:r>
           </a:p>
         </p:txBody>
@@ -4590,7 +4590,7 @@
         <p:spPr>
           <a:xfrm>
             <a:off x="571500" y="381000"/>
-            <a:ext cx="7620000" cy="254000"/>
+            <a:ext cx="10795000" cy="254000"/>
           </a:xfrm>
           <a:prstGeom prst="rect">
             <a:avLst/>
@@ -4615,7 +4615,7 @@
                 </a:solidFill>
                 <a:latin typeface="Tahoma"/>
               </a:rPr>
-              <a:t>INTERNET OF THAILAND · IoT</a:t>
+              <a:t>IoT (Internet of Things) · IoTE KMITL 2026 Showcase</a:t>
             </a:r>
           </a:p>
         </p:txBody>
@@ -4628,8 +4628,8 @@
         </p:nvSpPr>
         <p:spPr>
           <a:xfrm>
-            <a:off x="571500" y="1460500"/>
-            <a:ext cx="11049000" cy="1270000"/>
+            <a:off x="571500" y="1587500"/>
+            <a:ext cx="11049000" cy="1143000"/>
           </a:xfrm>
           <a:prstGeom prst="rect">
             <a:avLst/>
@@ -4648,13 +4648,13 @@
               </a:lnSpc>
             </a:pPr>
             <a:r>
-              <a:rPr sz="8500" b="1">
+              <a:rPr sz="6600" b="1">
                 <a:solidFill>
                   <a:srgbClr val="F2F6EE"/>
                 </a:solidFill>
                 <a:latin typeface="Tahoma"/>
               </a:rPr>
-              <a:t>เครื่องดมทุเรียน</a:t>
+              <a:t>เครื่องดมทุเรียนอัจฉริยะ</a:t>
             </a:r>
           </a:p>
         </p:txBody>
@@ -4668,7 +4668,7 @@
         <p:spPr>
           <a:xfrm>
             <a:off x="571500" y="2794000"/>
-            <a:ext cx="6350000" cy="825500"/>
+            <a:ext cx="10160000" cy="698500"/>
           </a:xfrm>
           <a:prstGeom prst="rect">
             <a:avLst/>
@@ -4687,13 +4687,13 @@
               </a:lnSpc>
             </a:pPr>
             <a:r>
-              <a:rPr sz="5000" b="1">
+              <a:rPr sz="3500" b="1">
                 <a:solidFill>
                   <a:srgbClr val="B9D84A"/>
                 </a:solidFill>
                 <a:latin typeface="Tahoma"/>
               </a:rPr>
-              <a:t>(e-nose)</a:t>
+              <a:t>จมูกอิเล็กทรอนิกส์ (e-nose)</a:t>
             </a:r>
           </a:p>
         </p:txBody>
@@ -5064,7 +5064,7 @@
                 </a:solidFill>
                 <a:latin typeface="Tahoma"/>
               </a:rPr>
-              <a:t>ทีม 3 คน · All for One University · สาย IoT · ผู้นำเสนอ ณัฐพฤทธ์ เอกประเสริฐ</a:t>
+              <a:t>ทีม พี่จร้าาา · IoTE KMITL 2026 · สาย IoT &amp; Innovation · ผู้นำเสนอ ณัฐพฤทธ์ เอกประเสริฐ</a:t>
             </a:r>
           </a:p>
         </p:txBody>
@@ -5129,7 +5129,7 @@
                 </a:solidFill>
                 <a:latin typeface="Tahoma"/>
               </a:rPr>
-              <a:t>เครื่องดมทุเรียน (e-nose)  ·  </a:t>
+              <a:t>เครื่องดมทุเรียนอัจฉริยะ  ·  </a:t>
             </a:r>
             <a:r>
               <a:rPr sz="1400" b="0">
@@ -5804,7 +5804,7 @@
                 </a:solidFill>
                 <a:latin typeface="Tahoma"/>
               </a:rPr>
-              <a:t>เครื่องดมทุเรียน (e-nose)  ·  </a:t>
+              <a:t>เครื่องดมทุเรียนอัจฉริยะ  ·  </a:t>
             </a:r>
             <a:r>
               <a:rPr sz="1400" b="0">
@@ -6479,7 +6479,7 @@
                 </a:solidFill>
                 <a:latin typeface="Tahoma"/>
               </a:rPr>
-              <a:t>เครื่องดมทุเรียน (e-nose)  ·  </a:t>
+              <a:t>เครื่องดมทุเรียนอัจฉริยะ  ·  </a:t>
             </a:r>
             <a:r>
               <a:rPr sz="1400" b="0">
@@ -7389,7 +7389,7 @@
                 </a:solidFill>
                 <a:latin typeface="Tahoma"/>
               </a:rPr>
-              <a:t>เครื่องดมทุเรียน (e-nose)  ·  </a:t>
+              <a:t>เครื่องดมทุเรียนอัจฉริยะ  ·  </a:t>
             </a:r>
             <a:r>
               <a:rPr sz="1400" b="0">
@@ -8523,7 +8523,7 @@
                 </a:solidFill>
                 <a:latin typeface="Tahoma"/>
               </a:rPr>
-              <a:t>เครื่องดมทุเรียน (e-nose)  ·  </a:t>
+              <a:t>เครื่องดมทุเรียนอัจฉริยะ  ·  </a:t>
             </a:r>
             <a:r>
               <a:rPr sz="1400" b="0">
@@ -9222,7 +9222,7 @@
                 </a:solidFill>
                 <a:latin typeface="Tahoma"/>
               </a:rPr>
-              <a:t>เครื่องดมทุเรียน (e-nose)  ·  </a:t>
+              <a:t>เครื่องดมทุเรียนอัจฉริยะ  ·  </a:t>
             </a:r>
             <a:r>
               <a:rPr sz="1400" b="0">
@@ -9597,7 +9597,7 @@
                 </a:solidFill>
                 <a:latin typeface="Tahoma"/>
               </a:rPr>
-              <a:t>ทีม 3 คน · All for One University · สาย IoT · ณัฐพฤทธ์ เอกประเสริฐ</a:t>
+              <a:t>ทีม พี่จร้าาา · สาย IoT &amp; Innovation · ผู้นำเสนอ ณัฐพฤทธ์ เอกประเสริฐ</a:t>
             </a:r>
           </a:p>
         </p:txBody>
@@ -9946,7 +9946,7 @@
                 </a:solidFill>
                 <a:latin typeface="Tahoma"/>
               </a:rPr>
-              <a:t>เครื่องดมทุเรียน (e-nose)  ·  </a:t>
+              <a:t>เครื่องดมทุเรียนอัจฉริยะ  ·  </a:t>
             </a:r>
             <a:r>
               <a:rPr sz="1400" b="0">
@@ -10405,7 +10405,7 @@
                 </a:solidFill>
                 <a:latin typeface="Tahoma"/>
               </a:rPr>
-              <a:t>เครื่องดมทุเรียน (e-nose)  ·  </a:t>
+              <a:t>เครื่องดมทุเรียนอัจฉริยะ  ·  </a:t>
             </a:r>
             <a:r>
               <a:rPr sz="1400" b="0">
@@ -11015,7 +11015,7 @@
                 </a:solidFill>
                 <a:latin typeface="Tahoma"/>
               </a:rPr>
-              <a:t>เครื่องดมทุเรียน (e-nose)  ·  </a:t>
+              <a:t>เครื่องดมทุเรียนอัจฉริยะ  ·  </a:t>
             </a:r>
             <a:r>
               <a:rPr sz="1400" b="0">
@@ -11808,7 +11808,7 @@
                 </a:solidFill>
                 <a:latin typeface="Tahoma"/>
               </a:rPr>
-              <a:t>เครื่องดมทุเรียน (e-nose)  ·  </a:t>
+              <a:t>เครื่องดมทุเรียนอัจฉริยะ  ·  </a:t>
             </a:r>
             <a:r>
               <a:rPr sz="1400" b="0">
@@ -12569,7 +12569,7 @@
                 </a:solidFill>
                 <a:latin typeface="Tahoma"/>
               </a:rPr>
-              <a:t>เครื่องดมทุเรียน (e-nose)  ·  </a:t>
+              <a:t>เครื่องดมทุเรียนอัจฉริยะ  ·  </a:t>
             </a:r>
             <a:r>
               <a:rPr sz="1400" b="0">
@@ -13869,7 +13869,7 @@
                 </a:solidFill>
                 <a:latin typeface="Tahoma"/>
               </a:rPr>
-              <a:t>เครื่องดมทุเรียน (e-nose)  ·  </a:t>
+              <a:t>เครื่องดมทุเรียนอัจฉริยะ  ·  </a:t>
             </a:r>
             <a:r>
               <a:rPr sz="1400" b="0">
@@ -14489,7 +14489,7 @@
                 </a:solidFill>
                 <a:latin typeface="Tahoma"/>
               </a:rPr>
-              <a:t>เครื่องดมทุเรียน (e-nose)  ·  </a:t>
+              <a:t>เครื่องดมทุเรียนอัจฉริยะ  ·  </a:t>
             </a:r>
             <a:r>
               <a:rPr sz="1400" b="0">
@@ -16077,7 +16077,7 @@
                 </a:solidFill>
                 <a:latin typeface="Tahoma"/>
               </a:rPr>
-              <a:t>เครื่องดมทุเรียน (e-nose)  ·  </a:t>
+              <a:t>เครื่องดมทุเรียนอัจฉริยะ  ·  </a:t>
             </a:r>
             <a:r>
               <a:rPr sz="1400" b="0">

</xml_diff>

<commit_message>
Final PoC PDF + page summary, deck v2 fix, 2-min pitch clip card, DS-300 green bin label; hide old v6 deck link
Co-Authored-By: Claude Opus 5.5 <noreply@anthropic.com>
</commit_message>
<xml_diff>
--- a/docs/e-nose-pitch-deck-v2.pptx
+++ b/docs/e-nose-pitch-deck-v2.pptx
@@ -1217,7 +1217,7 @@
           <a:lstStyle/>
           <a:p>
             <a:r>
-              <a:t>วิธีเดิมคือเคาะฟังเสียง นับวันหลังดอกบาน หรือผ่าวัดน้ำหนักแห้ง ซึ่งทำลายผล ลูกละราว 480 ถึง 640 บาท และทำได้แค่สุ่ม NIR และ GC-MS แพงหรือใช้หน้างานไม่ได้ เราค้นงานวิจัยสี่รอบ ยังไม่พบงาน e-nose ที่แยกทุเรียนเน่าจากปกติพร้อมรายงานความแม่นยำ นี่คือช่องว่างและโอกาสของเรา</a:t>
+              <a:t>วิธีเดิมคือเคาะฟังเสียง นับวันหลังดอกบาน หรือผ่าวัดน้ำหนักแห้ง ซึ่งทำลายผล จึงทำได้แค่สุ่ม NIR และ GC-MS แพงหรือใช้หน้างานไม่ได้ เราค้นงานวิจัยสี่รอบ ยังไม่พบงาน e-nose ที่แยกทุเรียนเน่าจากปกติพร้อมรายงานความแม่นยำ นี่คือช่องว่างและโอกาสของเรา</a:t>
             </a:r>
           </a:p>
         </p:txBody>
@@ -11253,7 +11253,7 @@
                 </a:solidFill>
                 <a:latin typeface="Tahoma"/>
               </a:rPr>
-              <a:t>ทำลายผล ~480–640 บาท/ลูก</a:t>
+              <a:t>ทำลายผล จึงทำได้แค่สุ่ม</a:t>
             </a:r>
           </a:p>
         </p:txBody>
@@ -11743,7 +11743,7 @@
                 </a:solidFill>
                 <a:latin typeface="Tahoma"/>
               </a:rPr>
-              <a:t>ที่มา: LINE Today (มกษ. 3-2567), ISHS · การค้นงานวิจัยของทีม</a:t>
+              <a:t>ที่มา: ประชาชาติธุรกิจ ผ่าน LINE Today (26 ก.พ. 2569), ISHS · การค้นงานวิจัยของทีม</a:t>
             </a:r>
           </a:p>
         </p:txBody>

</xml_diff>

<commit_message>
docs: republish deck v2 fix (latest render)
Co-Authored-By: Claude Opus 5.5 <noreply@anthropic.com>
</commit_message>
<xml_diff>
--- a/docs/e-nose-pitch-deck-v2.pptx
+++ b/docs/e-nose-pitch-deck-v2.pptx
@@ -1147,7 +1147,7 @@
           <a:lstStyle/>
           <a:p>
             <a:r>
-              <a:t>ทำไมเรื่องนี้ใหญ่ ทุเรียนคือ 72.9 เปอร์เซ็นต์ของผลไม้สดส่งออกของไทยในปี 2567 และปี 2568 ทุเรียนสดไปจีนอย่างเดียวมูลค่า 150,279 ล้านบาท ตัวเลขมาจาก MGR Online, Commerce News Agency และ Nation Thailand ตามที่ระบุในสไลด์ ล็อตเดียวที่เสียทำให้ทั้งตลาดเสียความเชื่อมั่น</a:t>
+              <a:t>ทำไมเรื่องนี้ใหญ่ ปี 2568 ทุเรียนสดส่งไปจีนราว 939,892 ตัน รวม 58,072 ชิปเมนต์ มูลค่าราว 150,279 ล้านบาท ตามรายงานของ Nation Thailand ขอบเขตข้อมูลอาจต่างจากสถิติส่งออกของไทย ล็อตเดียวที่เสียทำให้ทั้งตลาดเสียความเชื่อมั่น</a:t>
             </a:r>
           </a:p>
         </p:txBody>
@@ -10601,8 +10601,8 @@
         </p:nvSpPr>
         <p:spPr>
           <a:xfrm>
-            <a:off x="825500" y="1651000"/>
-            <a:ext cx="4826000" cy="1460500"/>
+            <a:off x="825500" y="1778000"/>
+            <a:ext cx="4826000" cy="1270000"/>
           </a:xfrm>
           <a:prstGeom prst="rect">
             <a:avLst/>
@@ -10621,13 +10621,13 @@
               </a:lnSpc>
             </a:pPr>
             <a:r>
-              <a:rPr sz="9500" b="1">
+              <a:rPr sz="7500" b="1">
                 <a:solidFill>
                   <a:srgbClr val="B9D84A"/>
                 </a:solidFill>
                 <a:latin typeface="Tahoma"/>
               </a:rPr>
-              <a:t>72.9%</a:t>
+              <a:t>939,892</a:t>
             </a:r>
           </a:p>
         </p:txBody>
@@ -10666,7 +10666,7 @@
                 </a:solidFill>
                 <a:latin typeface="Tahoma"/>
               </a:rPr>
-              <a:t>ของผลไม้สดส่งออกไทย</a:t>
+              <a:t>ตัน ทุเรียนสดไปจีน (ปี 2568)</a:t>
             </a:r>
           </a:p>
           <a:p>
@@ -10682,7 +10682,7 @@
                 </a:solidFill>
                 <a:latin typeface="Tahoma"/>
               </a:rPr>
-              <a:t>คือทุเรียน (ปี 2567)</a:t>
+              <a:t>58,072 ชิปเมนต์ ตามรายงาน*</a:t>
             </a:r>
           </a:p>
         </p:txBody>
@@ -10808,7 +10808,7 @@
                 </a:solidFill>
                 <a:latin typeface="Tahoma"/>
               </a:rPr>
-              <a:t>ล้านบาท</a:t>
+              <a:t>ล้านบาท มูลค่าทุเรียนสด</a:t>
             </a:r>
           </a:p>
           <a:p>
@@ -10824,7 +10824,7 @@
                 </a:solidFill>
                 <a:latin typeface="Tahoma"/>
               </a:rPr>
-              <a:t>ทุเรียนสดไปจีนอย่างเดียว (ปี 2568)</a:t>
+              <a:t>ไปจีน ตามรายงาน* (ปี 2568)</a:t>
             </a:r>
           </a:p>
         </p:txBody>
@@ -10950,7 +10950,7 @@
                 </a:solidFill>
                 <a:latin typeface="Tahoma"/>
               </a:rPr>
-              <a:t>ที่มา: MGR Online (mgronline.com/business/detail/9680000042916) · Commerce News Agency (commercenewsagency.com/columnist/7677) · Nation Thailand (nationthailand.com/business/trade/40063289)</a:t>
+              <a:t>ที่มา: Nation Thailand (nationthailand.com/business/trade/40063289) · *ขอบเขตข้อมูลอาจต่างจากสถิติส่งออกของไทย</a:t>
             </a:r>
           </a:p>
         </p:txBody>

</xml_diff>

<commit_message>
DS-301 PoC and deck; ds-301 page: concept note, BME688 x2, belt speed marked simulated
Co-Authored-By: Claude Opus 5.5 <noreply@anthropic.com>
</commit_message>
<xml_diff>
--- a/docs/e-nose-pitch-deck-v2.pptx
+++ b/docs/e-nose-pitch-deck-v2.pptx
@@ -517,7 +517,7 @@
           <a:lstStyle/>
           <a:p>
             <a:r>
-              <a:t>สวัสดีครับ วันนี้เสนอ "เครื่องดมทุเรียนอัจฉริยะ" เครื่องตรวจความสุกและการเสียของทุเรียนจากกลิ่น ด้วยเซนเซอร์แก๊สหลายตัวบน ESP32 มีสองรุ่นคือ DS-300 เครื่องคัดแบบพกพาสำหรับล้ง และ E-100 เครื่องตั้งโต๊ะสำหรับร้านพรีเมียม ทั้งสองรุ่นเป็นแนวคิด ยังไม่ได้สร้างจริง และเรายังไม่มีผลทดลองจากเครื่องของเราเอง</a:t>
+              <a:t>สวัสดีครับ วันนี้เสนอ "เครื่องดมทุเรียนอัจฉริยะ" เครื่องตรวจความสุกและการเสียของทุเรียนจากกลิ่น ด้วยเซนเซอร์แก๊สหลายตัวบน ESP32 มีสองรุ่นคือ DS-301 เครื่องคัดบนสายพานสำหรับล้ง และ E-100 เครื่องตั้งโต๊ะสำหรับร้านพรีเมียม ทั้งสองรุ่นเป็นแนวคิด ยังไม่ได้สร้างจริง และเรายังไม่มีผลทดลองจากเครื่องของเราเอง</a:t>
             </a:r>
           </a:p>
         </p:txBody>
@@ -587,7 +587,7 @@
           <a:lstStyle/>
           <a:p>
             <a:r>
-              <a:t>E-100 คือเครื่องดมหน้าร้าน เครื่องเล็กวางบนเคาน์เตอร์หรือแผงขาย ให้ลูกค้าเลือกทุเรียนพรีเมียมแล้วดมเช็กทีละลูกก่อนซื้อ ไฟเกรดและผลหันไปทางลูกค้า เพื่อให้ผู้ซื้อมั่นใจขึ้น ใช้ชุดเซนเซอร์เดียวกับ DS-300 เป็นแนวคิด ยังไม่ได้สร้างจริง ไม่ระบุน้ำหนัก แบตเตอรี่ หรือราคา</a:t>
+              <a:t>E-100 คือเครื่องดมหน้าร้าน เครื่องเล็กวางบนเคาน์เตอร์หรือแผงขาย ให้ลูกค้าเลือกทุเรียนพรีเมียมแล้วดมเช็กทีละลูกก่อนซื้อ ไฟเกรดและผลหันไปทางลูกค้า เพื่อให้ผู้ซื้อมั่นใจขึ้น ใช้ชุดเซนเซอร์เดียวกับ DS-301 เป็นแนวคิด ยังไม่ได้สร้างจริง ไม่ระบุน้ำหนักหรือราคา</a:t>
             </a:r>
           </a:p>
         </p:txBody>
@@ -727,7 +727,7 @@
           <a:lstStyle/>
           <a:p>
             <a:r>
-              <a:t>งบประมาณชุดต้นแบบมีสองแบบ ชุดเดิม TGS สองตัวกับ BME688 สองตัว ประมาณ 3,500 บาท ชุดประหยัด MQ-3 MQ-135 และ BME680 ประมาณ 1,400 ถึง 2,100 บาท ราคาจาก Lazada และ allnewstep วันที่ 26 ตุลาคม 2026 ไม่รวมค่าส่ง ไส้กรอง กล่อง และท่อ ชุดประหยัดเสียเซนเซอร์อมีนกำมะถันและตัวอ้างอิงอากาศ ความแม่นยำที่ลดลงตอบเป็นตัวเลขไม่ได้ ยังไม่มีราคาของ DS-300 และ E-100 เต็มเครื่อง ด้านธุรกิจ ลูกค้าหลักคือล้งและผู้ส่งออก ร้านพรีเมียมเป็นกลุ่มทดลองตลาด รายได้จากขายหรือให้เช่าเครื่อง และค่าสมาชิกรายฤดู ซึ่งเป็นข้อเสนอ ยังไม่ได้ทดสอบตลาด</a:t>
+              <a:t>งบประมาณชุดต้นแบบมีสองแบบ ชุดเดิม TGS สองตัวกับ BME688 สองตัว ประมาณ 3,500 บาท ชุดประหยัด MQ-3 MQ-135 และ BME680 ประมาณ 1,400 ถึง 2,100 บาท ราคาจาก Lazada และ allnewstep วันที่ 26 ตุลาคม 2026 ไม่รวมค่าส่ง ไส้กรอง กล่อง และท่อ ชุดประหยัดเสียเซนเซอร์อมีนกำมะถันและตัวอ้างอิงอากาศ ความแม่นยำที่ลดลงตอบเป็นตัวเลขไม่ได้ ยังไม่มีราคาของ DS-301 และ E-100 เต็มเครื่อง และยังไม่รวมสายพาน ด้านธุรกิจ ลูกค้าหลักคือล้งและผู้ส่งออก ร้านพรีเมียมเป็นกลุ่มทดลองตลาด รายได้จากขายหรือให้เช่าเครื่อง และค่าสมาชิกรายฤดู ซึ่งเป็นข้อเสนอ ยังไม่ได้ทดสอบตลาด</a:t>
             </a:r>
           </a:p>
         </p:txBody>
@@ -867,7 +867,7 @@
           <a:lstStyle/>
           <a:p>
             <a:r>
-              <a:t>ข้อจำกัดที่ต้องบอกตรงๆ ยังไม่มีผลทดลองจากเครื่องของเราเอง จึงไม่อ้างความแม่นยำ ยังไม่ได้ทดสอบกับทุเรียนจริง เซนเซอร์แก๊สราคาถูกวัดสารรายชนิดไม่ได้ และแยกทุเรียนอ่อนจากแก่จากกลิ่นอย่างเดียวยังไม่มีหลักฐาน งานวิจัยส่วนใหญ่เป็นห้องแล็บ Simulation เป็นค่าจำลอง DS-300 และ E-100 ยังไม่ได้สร้างจริง</a:t>
+              <a:t>ข้อจำกัดที่ต้องบอกตรงๆ ยังไม่มีผลทดลองจากเครื่องของเราเอง จึงไม่อ้างความแม่นยำ ยังไม่ได้ทดสอบกับทุเรียนจริง เซนเซอร์แก๊สราคาถูกวัดสารรายชนิดไม่ได้ และแยกทุเรียนอ่อนจากแก่จากกลิ่นอย่างเดียวยังไม่มีหลักฐาน งานวิจัยส่วนใหญ่เป็นห้องแล็บ Simulation เป็นค่าจำลอง DS-301 และ E-100 ยังไม่ได้สร้างจริง</a:t>
             </a:r>
           </a:p>
         </p:txBody>
@@ -937,7 +937,7 @@
           <a:lstStyle/>
           <a:p>
             <a:r>
-              <a:t>ทีม พี่จร้าาา สาย IoT &amp; Innovation ในงาน IoTE KMITL 2026 Showcase ผู้นำเสนอคือ ณัฐพฤทธ์ เอกประเสริฐ เราขอคำชี้แนะจากกรรมการสามข้อ หนึ่ง ควรเริ่มทดสอบ DS-300 ที่ล้ง หรือ E-100 ที่ร้านก่อน สอง ควรลงทุนเซนเซอร์ระดับ B ตั้งแต่ต้น หรือพิสูจน์ด้วยชุด A ก่อน สาม มีล้งหรือหน่วยงานไหนที่ควรติดต่อเพื่อเก็บข้อมูลจริง</a:t>
+              <a:t>ทีม พี่จร้าาา สาย IoT &amp; Innovation ในงาน IoTE KMITL 2026 Showcase ผู้นำเสนอคือ ณัฐพฤทธ์ เอกประเสริฐ เราขอคำชี้แนะจากกรรมการสามข้อ หนึ่ง ควรเริ่มทดสอบ DS-301 ที่ล้ง หรือ E-100 ที่ร้านก่อน สอง ควรลงทุนเซนเซอร์ระดับ B ตั้งแต่ต้น หรือพิสูจน์ด้วยชุด A ก่อน สาม มีล้งหรือหน่วยงานไหนที่ควรติดต่อเพื่อเก็บข้อมูลจริง</a:t>
             </a:r>
           </a:p>
         </p:txBody>
@@ -1007,7 +1007,7 @@
           <a:lstStyle/>
           <a:p>
             <a:r>
-              <a:t>ขอบคุณครับ สแกน QR เพื่อดูข้อมูลเพิ่มเติม Simulation เครื่อง DS-300 เครื่อง E-100 ห้องบ่มทุเรียน ผังต่อสาย และเอกสารทั้งหมดบนเว็บของทีม ค่าใน Simulation เป็นค่าจำลองทั้งหมด</a:t>
+              <a:t>ขอบคุณครับ สแกน QR เพื่อดูข้อมูลเพิ่มเติม Simulation เครื่อง DS-301 เครื่อง E-100 ห้องบ่มทุเรียน ผังต่อสาย และเอกสารทั้งหมดบนเว็บของทีม ค่าใน Simulation เป็นค่าจำลองทั้งหมด</a:t>
             </a:r>
           </a:p>
         </p:txBody>
@@ -1077,7 +1077,7 @@
           <a:lstStyle/>
           <a:p>
             <a:r>
-              <a:t>เริ่มจากข่าวจริงครับ พฤษภาคม 2569 เจ้าหน้าที่พบทุเรียนอ่อนกว่า 500 ลูกในล้งแห่งหนึ่งที่จันทบุรี ตอนบรรจุกล่องรอขึ้นรถแล้ว ที่ผ่านด่านไปแล้วก็ยังเสี่ยงสุกเกิน ขึ้นรา และถูกตีกลับที่ปลายทาง โดยไม่มีใครรู้ จนกว่าจะเปิดตู้</a:t>
+              <a:t>เริ่มจากข่าวจริงครับ พฤษภาคม 2569 เจ้าหน้าที่พบทุเรียนอ่อนกว่า 500 ลูกในล้งแห่งหนึ่งที่จันทบุรี และสั่งรื้อห้ามส่งออก ข่าวนี้บอกว่าการตรวจแบบสุ่มปล่อยลูกที่มีปัญหาหลุดได้ เครื่องของเราไม่ได้ตัดสินอ่อนหรือแก่ เพราะกลิ่นแยกไม่ได้ แต่ดมหาลูกที่สุกเกินหรือเริ่มเสียทีละลูก ซึ่งเป็นความเสี่ยงระหว่างขนส่งที่ไม่มีใครรู้จนเปิดตู้</a:t>
             </a:r>
           </a:p>
         </p:txBody>
@@ -1147,7 +1147,7 @@
           <a:lstStyle/>
           <a:p>
             <a:r>
-              <a:t>ทำไมเรื่องนี้ใหญ่ ปี 2568 ทุเรียนสดส่งไปจีนราว 939,892 ตัน รวม 58,072 ชิปเมนต์ มูลค่าราว 150,279 ล้านบาท ตามรายงานของ Nation Thailand ขอบเขตข้อมูลอาจต่างจากสถิติส่งออกของไทย ล็อตเดียวที่เสียทำให้ทั้งตลาดเสียความเชื่อมั่น</a:t>
+              <a:t>ทำไมเรื่องนี้ใหญ่ ปี 2568 ทุเรียนสดส่งไปจีนราว 939,892 ตัน รวม 58,072 ชิปเมนต์ มูลค่าราว 150,279 ล้านบาท ตามรายงานของ Nation Thailand ขอบเขตข้อมูลอาจต่างจากสถิติส่งออกของไทย ทีมคำนวณว่าต่อชิปเมนต์เฉลี่ยราว 16 ตัน มูลค่าราว 2.6 ล้านบาท เป็นมูลค่าที่เสี่ยง ไม่ใช่ตัวเลขความเสียหาย</a:t>
             </a:r>
           </a:p>
         </p:txBody>
@@ -1217,7 +1217,7 @@
           <a:lstStyle/>
           <a:p>
             <a:r>
-              <a:t>วิธีเดิมคือเคาะฟังเสียง นับวันหลังดอกบาน หรือผ่าวัดน้ำหนักแห้ง ซึ่งทำลายผล จึงทำได้แค่สุ่ม NIR และ GC-MS แพงหรือใช้หน้างานไม่ได้ เราค้นงานวิจัยสี่รอบ ยังไม่พบงาน e-nose ที่แยกทุเรียนเน่าจากปกติพร้อมรายงานความแม่นยำ นี่คือช่องว่างและโอกาสของเรา</a:t>
+              <a:t>วิธีเดิมคือเคาะฟังเสียง นับวันหลังดอกบาน หรือผ่าวัดน้ำหนักแห้ง ซึ่งทำลายผล จึงทำได้แค่สุ่ม NIR และ GC-MS แพงหรือใช้หน้างานไม่ได้ ทีมค้นงานวิจัยสี่รอบ ยังไม่พบงาน e-nose ที่แยกทุเรียนเน่าจากปกติพร้อมรายงานความแม่นยำ นี่เป็นการค้นของทีม ไม่ได้อ้างว่าไม่มีอยู่ งานที่ใกล้ที่สุดคือ Chiu และคณะ ปี 2025 ใช้ e-nose ราคาถูกกับทุเรียนไทย ต่างจากเราตรงที่เราออกแบบระดับไม่แน่ใจ และสองเครื่องสำหรับล้งและหน้าร้าน เรายังไม่มีผลวัด จึงไม่เทียบความแม่นยำ</a:t>
             </a:r>
           </a:p>
         </p:txBody>
@@ -1357,7 +1357,7 @@
           <a:lstStyle/>
           <a:p>
             <a:r>
-              <a:t>วิธีตัดสินที่วางแผนไว้ เซนเซอร์แต่ละตัวอ่านค่าความต้านทาน Rs ต่อ R0 ที่ลดลงเมื่อมีกลิ่น เรารวมค่าของเซนเซอร์หลายตัวเป็นลายนิ้วมือกลิ่นของลูกนั้น แล้วเทียบกับค่าอ้างอิงของแต่ละเกรดที่ได้จากการสอบเทียบ ถ้าใกล้เกรดใดชัดเจนก็แสดงเกรดนั้น ถ้าก้ำกึ่งหรือห่างจากทุกเกรด แสดงไม่แน่ใจและให้คนตรวจ ภาพแท่งในสไลด์เป็นภาพประกอบ ไม่มีตัวเลข ค่าเกณฑ์จริงต้องได้จากข้อมูลทุเรียนจริงก่อน</a:t>
+              <a:t>วิธีตัดสินที่วางแผนไว้ เซนเซอร์แต่ละตัวอ่านค่าความต้านทาน Rs ต่อ R0 ที่ลดลงเมื่อมีกลิ่น เรารวมค่าของเซนเซอร์หลายตัวเป็นลายนิ้วมือกลิ่นของลูกนั้น แล้วเทียบกับค่าอ้างอิงของแต่ละเกรดที่จะได้จากการสอบเทียบ ถ้าใกล้เกรดใดชัดเจนก็แสดงเกรดนั้น ถ้าก้ำกึ่งหรือห่างจากทุกเกรด แสดงไม่แน่ใจและให้คนตรวจ ภาพแท่งในสไลด์เป็นภาพประกอบ ไม่มีตัวเลข ค่าเกณฑ์จริงต้องได้จากข้อมูลทุเรียนจริงก่อน</a:t>
             </a:r>
           </a:p>
         </p:txBody>
@@ -1567,7 +1567,7 @@
           <a:lstStyle/>
           <a:p>
             <a:r>
-              <a:t>DS-300 คือเครื่องคัดแบบพกพาสำหรับล้ง แนวคิดคือตู้ขนาดกระเป๋าเดินทางราว 70 คูณ 55 คูณ 65 เซนติเมตร มีล้อลากและหูหิ้ว มีห้องดมตรวจทีละลูกผ่านรอบวัดเส้นฐาน สะสมกลิ่น ดม และล้าง แล้วคัดลงลังสี่ช่อง คือ อ่อน สุก สุกเกินหรือเริ่มเสีย และไม่แน่ใจ ส่งคนตรวจ เกรดอ่อนเป็นแนวคิด เพราะยังไม่มีหลักฐานว่าแยกทุเรียนอ่อนจากกลิ่นได้ เครื่องนี้ยังไม่ได้สร้างจริง ไม่ระบุน้ำหนักหรือแบตเตอรี่</a:t>
+              <a:t>DS-301 คือเครื่องคัดบนสายพานสำหรับโรงคัดของล้ง สายพานป้อนทุเรียนเข้าตู้ห้องดมที่คร่อมสายพาน มีประตูหน้าและหลัง ขนาดแนวคิดราว 70 คูณ 55 คูณ 65 เซนติเมตร ดมทีละลูกผ่านรอบวัดเส้นฐาน สะสมกลิ่น ดม และล้าง แล้วตัวแยกเลนส่งลงลังสี่ช่องตามไฟเกรดสี่ดวง คือ ยังไม่สุกจากกลิ่นซึ่งเป็นแนวคิดเท่านั้น สุก สุกเกินหรือเริ่มเสีย และไม่แน่ใจส่งคนตรวจ อัตราคัดสูงสุดราว 24 ลูกต่อชั่วโมงต่อห้องดม เป็นประมาณการของทีม สายพานไม่เพิ่มอัตรานี้ ต้องเพิ่มห้องดม มอเตอร์สายพาน ประตู และตัวแยกเลนยังไม่ได้ออกแบบวงจร เครื่องนี้ยังไม่ได้สร้างจริง</a:t>
             </a:r>
           </a:p>
         </p:txBody>
@@ -4819,7 +4819,7 @@
                 </a:solidFill>
                 <a:latin typeface="Tahoma"/>
               </a:rPr>
-              <a:t>DS-300</a:t>
+              <a:t>DS-301</a:t>
             </a:r>
           </a:p>
           <a:p>
@@ -4835,7 +4835,7 @@
                 </a:solidFill>
                 <a:latin typeface="Tahoma"/>
               </a:rPr>
-              <a:t>เครื่องคัด · พกพา</a:t>
+              <a:t>เครื่องคัด · สายพาน</a:t>
             </a:r>
           </a:p>
         </p:txBody>
@@ -5700,7 +5700,7 @@
                 </a:solidFill>
                 <a:latin typeface="Tahoma"/>
               </a:rPr>
-              <a:t>ใช้ชุดเซนเซอร์เดียวกับ DS-300</a:t>
+              <a:t>ใช้ชุดเซนเซอร์เดียวกับ DS-301</a:t>
             </a:r>
           </a:p>
         </p:txBody>
@@ -7079,7 +7079,7 @@
                 </a:solidFill>
                 <a:latin typeface="Tahoma"/>
               </a:rPr>
-              <a:t>ล้ง/ผู้ส่งออก → DS-300</a:t>
+              <a:t>ล้ง/ผู้ส่งออก → DS-301</a:t>
             </a:r>
           </a:p>
         </p:txBody>
@@ -7285,7 +7285,7 @@
                 </a:solidFill>
                 <a:latin typeface="Tahoma"/>
               </a:rPr>
-              <a:t>ยังไม่มีราคา DS-300 / E-100 เต็มเครื่อง</a:t>
+              <a:t>ยังไม่มีราคา DS-301 / E-100 เต็มเครื่อง (ไม่รวมสายพาน)</a:t>
             </a:r>
           </a:p>
         </p:txBody>
@@ -7324,7 +7324,7 @@
                 </a:solidFill>
                 <a:latin typeface="Tahoma"/>
               </a:rPr>
-              <a:t>ราคา Lazada/allnewstep 26 ต.ค. 2026 · ไม่รวมค่าส่ง ไส้กรอง กล่อง ท่อ · ใช้ ESP8266 ที่มีอยู่ · รายได้ยังไม่ได้ทดสอบตลาด</a:t>
+              <a:t>ราคา Lazada/allnewstep 26 ต.ค. 2026 · ไม่รวมค่าส่ง ไส้กรอง กล่อง ท่อ สายพาน · ใช้ ESP8266 ที่มีอยู่ · รายได้ยังไม่ได้ทดสอบตลาด</a:t>
             </a:r>
           </a:p>
         </p:txBody>
@@ -9118,7 +9118,7 @@
                 </a:solidFill>
                 <a:latin typeface="Tahoma"/>
               </a:rPr>
-              <a:t>DS-300 / E-100 = ยังไม่สร้าง</a:t>
+              <a:t>DS-301 / E-100 = ยังไม่สร้าง</a:t>
             </a:r>
           </a:p>
         </p:txBody>
@@ -9366,7 +9366,7 @@
                 </a:solidFill>
                 <a:latin typeface="Tahoma"/>
               </a:rPr>
-              <a:t>เริ่มทดสอบ DS-300 ที่ล้ง หรือ E-100 ที่ร้านก่อน?</a:t>
+              <a:t>เริ่มทดสอบ DS-301 ที่ล้ง หรือ E-100 ที่ร้านก่อน?</a:t>
             </a:r>
           </a:p>
         </p:txBody>
@@ -9787,7 +9787,7 @@
                 </a:solidFill>
                 <a:latin typeface="Tahoma"/>
               </a:rPr>
-              <a:t>Simulation · เครื่อง DS-300 · E-100</a:t>
+              <a:t>Simulation · เครื่อง DS-301 · E-100</a:t>
             </a:r>
           </a:p>
           <a:p>
@@ -9994,7 +9994,7 @@
                 </a:solidFill>
                 <a:latin typeface="Tahoma"/>
               </a:rPr>
-              <a:t>ถ้าไม่มีใครตรวจ…</a:t>
+              <a:t>ตรวจแบบสุ่ม ลูกที่มีปัญหาหลุดได้</a:t>
             </a:r>
           </a:p>
         </p:txBody>
@@ -10192,13 +10192,13 @@
               </a:lnSpc>
             </a:pPr>
             <a:r>
-              <a:rPr sz="2800" b="1">
+              <a:rPr sz="2600" b="1">
                 <a:solidFill>
                   <a:srgbClr val="F2F6EE"/>
                 </a:solidFill>
                 <a:latin typeface="Tahoma"/>
               </a:rPr>
-              <a:t>ทุเรียนอ่อน พบในล้งที่จันทบุรี ตอนบรรจุกล่อง รอขึ้นรถแล้ว</a:t>
+              <a:t>ทุเรียนอ่อนหลุดการสุ่มตรวจ พบในล้งที่จันทบุรี สั่งรื้อ ห้ามส่งออก</a:t>
             </a:r>
           </a:p>
         </p:txBody>
@@ -10279,13 +10279,13 @@
               </a:lnSpc>
             </a:pPr>
             <a:r>
-              <a:rPr sz="2400" b="1">
+              <a:rPr sz="2200" b="1">
                 <a:solidFill>
                   <a:srgbClr val="F2F6EE"/>
                 </a:solidFill>
                 <a:latin typeface="Tahoma"/>
               </a:rPr>
-              <a:t>ที่ผ่านด่านไปได้ ก็ยังเสี่ยงสุกเกิน · ขึ้นรา · ถูกตีกลับ</a:t>
+              <a:t>เครื่องนี้ดมหาลูกสุกเกิน/เริ่มเสีย ไม่ได้ตัดสินอ่อน/แก่</a:t>
             </a:r>
           </a:p>
           <a:p>
@@ -10295,13 +10295,13 @@
               </a:lnSpc>
             </a:pPr>
             <a:r>
-              <a:rPr sz="2400" b="1">
+              <a:rPr sz="2200" b="1">
                 <a:solidFill>
                   <a:srgbClr val="E3A21A"/>
                 </a:solidFill>
                 <a:latin typeface="Tahoma"/>
               </a:rPr>
-              <a:t>โดยไม่มีใครรู้ จนเปิดตู้</a:t>
+              <a:t>ความเสี่ยงสุกเกินระหว่างขนส่ง ไม่มีใครรู้จนเปิดตู้ (ทีมประเมิน)</a:t>
             </a:r>
           </a:p>
         </p:txBody>
@@ -10905,13 +10905,29 @@
               </a:lnSpc>
             </a:pPr>
             <a:r>
-              <a:rPr sz="2600" b="1">
+              <a:rPr sz="2000" b="1">
                 <a:solidFill>
                   <a:srgbClr val="F2F6EE"/>
                 </a:solidFill>
                 <a:latin typeface="Tahoma"/>
               </a:rPr>
-              <a:t>ล็อตเดียวที่เสีย → ทั้งตลาดเสียความเชื่อมั่น</a:t>
+              <a:t>ต่อชิปเมนต์เฉลี่ยราว 2.6 ล้านบาท (ประมาณ · คำนวณโดยทีม)</a:t>
+            </a:r>
+          </a:p>
+          <a:p>
+            <a:pPr algn="ctr">
+              <a:lnSpc>
+                <a:spcPct val="115000"/>
+              </a:lnSpc>
+            </a:pPr>
+            <a:r>
+              <a:rPr sz="2000" b="1">
+                <a:solidFill>
+                  <a:srgbClr val="E3A21A"/>
+                </a:solidFill>
+                <a:latin typeface="Tahoma"/>
+              </a:rPr>
+              <a:t>มูลค่าที่เสี่ยง ไม่ใช่ตัวเลขความเสียหาย</a:t>
             </a:r>
           </a:p>
         </p:txBody>
@@ -11662,8 +11678,8 @@
         </p:nvSpPr>
         <p:spPr>
           <a:xfrm>
-            <a:off x="825500" y="5016500"/>
-            <a:ext cx="10541000" cy="952500"/>
+            <a:off x="825500" y="4953000"/>
+            <a:ext cx="10541000" cy="1016000"/>
           </a:xfrm>
           <a:prstGeom prst="rect">
             <a:avLst/>
@@ -11682,13 +11698,13 @@
               </a:lnSpc>
             </a:pPr>
             <a:r>
-              <a:rPr sz="2300" b="1">
+              <a:rPr sz="1600" b="1">
                 <a:solidFill>
                   <a:srgbClr val="F2F6EE"/>
                 </a:solidFill>
                 <a:latin typeface="Tahoma"/>
               </a:rPr>
-              <a:t>ค้น 4 รอบ ไม่พบ e-nose ที่แยกทุเรียนเน่า vs ปกติ พร้อมความแม่นยำ</a:t>
+              <a:t>ค้น 4 รอบ ไม่พบ e-nose แยกทุเรียนเน่า vs ปกติ พร้อมความแม่นยำ (การค้นของทีม ไม่ได้อ้างว่าไม่มีอยู่)</a:t>
             </a:r>
           </a:p>
           <a:p>
@@ -11698,13 +11714,13 @@
               </a:lnSpc>
             </a:pPr>
             <a:r>
-              <a:rPr sz="2300" b="1">
-                <a:solidFill>
-                  <a:srgbClr val="F2F6EE"/>
-                </a:solidFill>
-                <a:latin typeface="Tahoma"/>
-              </a:rPr>
-              <a:t>= โอกาสของเรา</a:t>
+              <a:rPr sz="1600" b="1">
+                <a:solidFill>
+                  <a:srgbClr val="A3B6AA"/>
+                </a:solidFill>
+                <a:latin typeface="Tahoma"/>
+              </a:rPr>
+              <a:t>ใกล้สุด: Chiu et al. 2025 (e-nose ทุเรียนไทย) · ต่างที่เรามี "ไม่แน่ใจ" + 2 เครื่องภาคสนาม · ไม่เทียบความแม่นยำ</a:t>
             </a:r>
           </a:p>
         </p:txBody>
@@ -11743,7 +11759,7 @@
                 </a:solidFill>
                 <a:latin typeface="Tahoma"/>
               </a:rPr>
-              <a:t>ที่มา: ประชาชาติธุรกิจ ผ่าน LINE Today (26 ก.พ. 2569), ISHS · การค้นงานวิจัยของทีม</a:t>
+              <a:t>ที่มา: ประชาชาติธุรกิจ ผ่าน LINE Today (26 ก.พ. 2569), ISHS · การค้นงานวิจัยของทีม · Chiu et al. 2025, PeerJ 13:e19936</a:t>
             </a:r>
           </a:p>
         </p:txBody>
@@ -13211,7 +13227,7 @@
                 </a:solidFill>
                 <a:latin typeface="Tahoma"/>
               </a:rPr>
-              <a:t>เทียบเกณฑ์สอบเทียบ</a:t>
+              <a:t>เทียบเกณฑ์ (จะสอบเทียบ)</a:t>
             </a:r>
           </a:p>
         </p:txBody>
@@ -13434,13 +13450,13 @@
               </a:lnSpc>
             </a:pPr>
             <a:r>
-              <a:rPr sz="2200" b="1">
+              <a:rPr sz="1700" b="1">
                 <a:solidFill>
                   <a:srgbClr val="4CAF50"/>
                 </a:solidFill>
                 <a:latin typeface="Tahoma"/>
               </a:rPr>
-              <a:t>สด</a:t>
+              <a:t>ยังไม่สุก (จากกลิ่น)*</a:t>
             </a:r>
           </a:p>
         </p:txBody>
@@ -13608,13 +13624,13 @@
               </a:lnSpc>
             </a:pPr>
             <a:r>
-              <a:rPr sz="2200" b="1">
+              <a:rPr sz="1900" b="1">
                 <a:solidFill>
                   <a:srgbClr val="E58A3F"/>
                 </a:solidFill>
                 <a:latin typeface="Tahoma"/>
               </a:rPr>
-              <a:t>เริ่มเน่า</a:t>
+              <a:t>สุกเกิน/เริ่มเสีย</a:t>
             </a:r>
           </a:p>
         </p:txBody>
@@ -13695,13 +13711,13 @@
               </a:lnSpc>
             </a:pPr>
             <a:r>
-              <a:rPr sz="2000" b="1">
-                <a:solidFill>
-                  <a:srgbClr val="E5766B"/>
-                </a:solidFill>
-                <a:latin typeface="Tahoma"/>
-              </a:rPr>
-              <a:t>เน่า / ไม่แน่ใจ</a:t>
+              <a:rPr sz="1900" b="1">
+                <a:solidFill>
+                  <a:srgbClr val="6FB7FF"/>
+                </a:solidFill>
+                <a:latin typeface="Tahoma"/>
+              </a:rPr>
+              <a:t>ไม่แน่ใจ → คนตรวจ</a:t>
             </a:r>
           </a:p>
         </p:txBody>
@@ -16125,7 +16141,7 @@
                 </a:solidFill>
                 <a:latin typeface="Tahoma"/>
               </a:rPr>
-              <a:t>DS-300 · คัดทีละลูกที่ล้ง</a:t>
+              <a:t>DS-301 · คัดบนสายพานที่ล้ง</a:t>
             </a:r>
           </a:p>
         </p:txBody>
@@ -16225,12 +16241,12 @@
         </p:nvSpPr>
         <p:spPr>
           <a:xfrm>
-            <a:off x="533400" y="1651000"/>
-            <a:ext cx="7442200" cy="3867150"/>
+            <a:off x="533400" y="1536700"/>
+            <a:ext cx="7442200" cy="4102100"/>
           </a:xfrm>
           <a:prstGeom prst="roundRect">
             <a:avLst>
-              <a:gd name="adj" fmla="val 2955"/>
+              <a:gd name="adj" fmla="val 2786"/>
             </a:avLst>
           </a:prstGeom>
           <a:solidFill>
@@ -16267,7 +16283,7 @@
       </p:sp>
       <p:pic>
         <p:nvPicPr>
-          <p:cNvPr id="7" name="Picture 6" descr="crop-ds300.png"/>
+          <p:cNvPr id="7" name="Picture 6" descr="crop-ds301.png"/>
           <p:cNvPicPr>
             <a:picLocks noChangeAspect="1"/>
           </p:cNvPicPr>
@@ -16281,8 +16297,8 @@
         </p:blipFill>
         <p:spPr>
           <a:xfrm>
-            <a:off x="571500" y="1689100"/>
-            <a:ext cx="7366000" cy="3790950"/>
+            <a:off x="571500" y="1574800"/>
+            <a:ext cx="7366000" cy="4025900"/>
           </a:xfrm>
           <a:prstGeom prst="rect">
             <a:avLst/>
@@ -16365,13 +16381,29 @@
               </a:lnSpc>
             </a:pPr>
             <a:r>
-              <a:rPr sz="2000" b="1">
+              <a:rPr sz="1700" b="1">
                 <a:solidFill>
                   <a:srgbClr val="F2F6EE"/>
                 </a:solidFill>
                 <a:latin typeface="Tahoma"/>
               </a:rPr>
-              <a:t>ดมทีละลูก → ล้าง</a:t>
+              <a:t>สายพาน → ห้องดม</a:t>
+            </a:r>
+          </a:p>
+          <a:p>
+            <a:pPr algn="ctr">
+              <a:lnSpc>
+                <a:spcPct val="115000"/>
+              </a:lnSpc>
+            </a:pPr>
+            <a:r>
+              <a:rPr sz="1700" b="1">
+                <a:solidFill>
+                  <a:srgbClr val="F2F6EE"/>
+                </a:solidFill>
+                <a:latin typeface="Tahoma"/>
+              </a:rPr>
+              <a:t>(ประตูหน้า/หลัง)</a:t>
             </a:r>
           </a:p>
         </p:txBody>
@@ -16452,13 +16484,29 @@
               </a:lnSpc>
             </a:pPr>
             <a:r>
-              <a:rPr sz="2000" b="1">
+              <a:rPr sz="1700" b="1">
                 <a:solidFill>
                   <a:srgbClr val="F2F6EE"/>
                 </a:solidFill>
                 <a:latin typeface="Tahoma"/>
               </a:rPr>
-              <a:t>คัดลงลัง 4 ช่อง</a:t>
+              <a:t>ตัวแยกเลน →</a:t>
+            </a:r>
+          </a:p>
+          <a:p>
+            <a:pPr algn="ctr">
+              <a:lnSpc>
+                <a:spcPct val="115000"/>
+              </a:lnSpc>
+            </a:pPr>
+            <a:r>
+              <a:rPr sz="1700" b="1">
+                <a:solidFill>
+                  <a:srgbClr val="F2F6EE"/>
+                </a:solidFill>
+                <a:latin typeface="Tahoma"/>
+              </a:rPr>
+              <a:t>ลัง 4 ช่องตามไฟเกรด</a:t>
             </a:r>
           </a:p>
         </p:txBody>
@@ -16539,13 +16587,29 @@
               </a:lnSpc>
             </a:pPr>
             <a:r>
-              <a:rPr sz="1900" b="1">
+              <a:rPr sz="1500" b="1">
                 <a:solidFill>
                   <a:srgbClr val="F2F6EE"/>
                 </a:solidFill>
                 <a:latin typeface="Tahoma"/>
               </a:rPr>
-              <a:t>ใช้ที่ลานคัด (ฝ่าย QC)</a:t>
+              <a:t>สูงสุด ~24 ลูก/ชม./ห้องดม</a:t>
+            </a:r>
+          </a:p>
+          <a:p>
+            <a:pPr algn="ctr">
+              <a:lnSpc>
+                <a:spcPct val="115000"/>
+              </a:lnSpc>
+            </a:pPr>
+            <a:r>
+              <a:rPr sz="1500" b="1">
+                <a:solidFill>
+                  <a:srgbClr val="F2F6EE"/>
+                </a:solidFill>
+                <a:latin typeface="Tahoma"/>
+              </a:rPr>
+              <a:t>(ประมาณการทีม)</a:t>
             </a:r>
           </a:p>
         </p:txBody>
@@ -16648,7 +16712,7 @@
                 </a:solidFill>
                 <a:latin typeface="Tahoma"/>
               </a:rPr>
-              <a:t>* เกรด "อ่อน" เป็นแนวคิด — ยังไม่มีหลักฐานจากกลิ่น</a:t>
+              <a:t>สายพาน/ประตู/ตัวแยกเลน ยังไม่ได้ออกแบบวงจร</a:t>
             </a:r>
           </a:p>
         </p:txBody>
@@ -16687,7 +16751,7 @@
                 </a:solidFill>
                 <a:latin typeface="Tahoma"/>
               </a:rPr>
-              <a:t>จำลองบนเว็บ · ขนาดโดยประมาณ (แนวคิด) ~70 × 55 × 65 ซม. · ไม่ระบุน้ำหนัก/แบตเตอรี่/ราคา</a:t>
+              <a:t>จำลองบนเว็บ moolek02.github.io/e-nose-hub/ds-301-grader.html · ตู้ห้องดม (แนวคิด) ~70 × 55 × 65 ซม. · สายพานไม่เพิ่มอัตราคัด ต้องเพิ่มห้องดม · ไม่ระบุราคา</a:t>
             </a:r>
           </a:p>
         </p:txBody>

</xml_diff>